<commit_message>
feat(presentation): reorder deck to mandate problem/solution, prior-art/gaps, workflow pipeline, results, related content, and future improvements
</commit_message>
<xml_diff>
--- a/SafeAdapt_Presentation_Updated.pptx
+++ b/SafeAdapt_Presentation_Updated.pptx
@@ -1445,7 +1445,32 @@
           </a:p>
           <a:p>
             <a:r>
-              <a:t>In conclusion, SafeAdapt transforms test-time adaptation into a robust, clinically certified safety framework. Our complete PyTorch codebase, model checkpoints, and reproduction scripts are released under an open-source license. We are actively integrating SafeAdapt into QuPath and Orthanc PACS for prospective multi-scanner clinical trials, and extending it to pathology foundation models (CONCH, UNI). Thank you very much for your time and guidance. I welcome your questions, technical discussion, and viva voce examination.</a:t>
+              <a:t>On our final slide, we present future improvements, clinical translation, and our open-source roadmap.</a:t>
+            </a:r>
+          </a:p>
+          <a:p>
+            <a:r>
+              <a:t>1. Foundation Model Extensions: Extending SafeAdapt to large pathology foundation models like CONCH and UNI using low-rank LoRA adapters.</a:t>
+            </a:r>
+          </a:p>
+          <a:p>
+            <a:r>
+              <a:t>2. Intraoperative &amp; 3D Histology: Deploying SafeAdapt to rapid intraoperative frozen sections where surgeons need answers in under 15 minutes, and extending OT alignment to 3D volumetric histology.</a:t>
+            </a:r>
+          </a:p>
+          <a:p>
+            <a:r>
+              <a:t>3. Clinical Translation: Complete open-source PyTorch release, with live integration into QuPath and Orthanc PACS for prospective multi-scanner trials.</a:t>
+            </a:r>
+          </a:p>
+          <a:p>
+            <a:r>
+              <a:t>SafeAdapt bridges the gap between academic TTA research and dependable clinical cancer diagnosis.</a:t>
+            </a:r>
+          </a:p>
+          <a:p>
+            <a:r>
+              <a:t>Thank you very much for your time and guidance. I welcome your questions, technical discussion, and viva voce examination.</a:t>
             </a:r>
           </a:p>
           <a:p/>
@@ -1462,7 +1487,7 @@
           <a:p/>
           <a:p>
             <a:r>
-              <a:t>KEY HIGHLIGHTS: Open-source PyTorch release; QuPath/PACS integration; ready for viva Q&amp;A.</a:t>
+              <a:t>KEY HIGHLIGHTS: Open-source PyTorch release; QuPath/PACS integration; Foundation models roadmap; ready for viva Q&amp;A.</a:t>
             </a:r>
           </a:p>
         </p:txBody>
@@ -1537,7 +1562,22 @@
           </a:p>
           <a:p>
             <a:r>
-              <a:t>In digital pathology, cancer diagnosis begins by digitizing tissue slices into multi-gigabyte Whole-Slide Images. Across hospitals, hardware digitizers (Hamamatsu, Philips, Leica), lens calibrations, and chemical staining concentrations vary significantly. A model trained at Radboud University achieving over 0.98 AUROC plummets to 0.73 AUROC when tested at CWZ or UMC Utrecht. Crucially, the model does not express uncertainty—it fails silently with high confidence on misclassified tissue.</a:t>
+              <a:t>Slide 2 establishes the core foundation: What is the problem statement? What are we solving? And what is our solution?</a:t>
+            </a:r>
+          </a:p>
+          <a:p>
+            <a:r>
+              <a:t>The problem statement: Deep learning models trained at one hospital fail when deployed to external hospital networks due to hardware scanner differences and chemical staining variations—dropping AUROC from 0.98 down to 0.73.</a:t>
+            </a:r>
+          </a:p>
+          <a:p>
+            <a:r>
+              <a:t>What are we solving? We are solving the dangerous reality of silent diagnostic failure: models fail with 99% confidence, missing metastatic cancer on unlabelled patient slides where no human annotations are available.</a:t>
+            </a:r>
+          </a:p>
+          <a:p>
+            <a:r>
+              <a:t>Our solution: SafeAdapt. A fail-closed, real-time adaptation framework that uses Optimal Transport to preserve category geometry, Cross-Attention Memory Routing to filter artifacts, and finite-sample Conformal Risk Control with 1.8 ms rollback to guarantee zero collapse.</a:t>
             </a:r>
           </a:p>
           <a:p/>
@@ -1548,13 +1588,13 @@
           </a:p>
           <a:p>
             <a:r>
-              <a:t>Imagine an expert human pathologist walking into a clinic where lights are tinted deep yellow and the microscope lenses are tinted blue. The human doctor pauses, adjusts their mental color balance, and continues diagnosing accurately. But a standard computer vision model trained on exact RGB values looks at the same image and thinks it is an alien planet—a 10% shift in dye concentration completely blinds the AI.</a:t>
+              <a:t>Reading Through Tinted Sunglasses: Imagine an expert human pathologist walking into a clinic where lights are tinted deep yellow and the microscope lenses are tinted blue. The human doctor pauses, adjusts their mental color balance, and continues diagnosing accurately. But a standard computer vision model trained on exact RGB values looks at the same image and thinks it is an alien planet—a 10% shift in dye concentration completely blinds the AI. SafeAdapt provides that autonomous mental color balance with a built-in safety net.</a:t>
             </a:r>
           </a:p>
           <a:p/>
           <a:p>
             <a:r>
-              <a:t>KEY HIGHLIGHTS: AUROC drop from &gt;0.98 to 0.73 across centers; 3-5 µm slice thickness variability.</a:t>
+              <a:t>KEY HIGHLIGHTS: AUROC drop from &gt;0.98 to 0.73; silent 99% confident failures; SafeAdapt fail-closed solution.</a:t>
             </a:r>
           </a:p>
         </p:txBody>
@@ -1629,7 +1669,22 @@
           </a:p>
           <a:p>
             <a:r>
-              <a:t>In computer vision, the standard technique to adapt models during inference is Test-Time Adaptation, like Tent or EATA, which minimize Shannon prediction entropy. In digital pathology, this logic is fatal. Extreme stain shifts produce moderate entropy on false predictions; forcing entropy down reinforces the wrong class assignments. This creates an unsupervised feedback loop that pulls all feature embeddings into a single degenerate 'attractor state'. On CAMELYON17 Center 4, Tent collapsed on 40% of slides, driving cancer detection F1 down to 0.05.</a:t>
+              <a:t>On Slide 3, we analyze the relevant research, the critical gaps in prior art, and exactly what we are doing differently.</a:t>
+            </a:r>
+          </a:p>
+          <a:p>
+            <a:r>
+              <a:t>Relevant research: In computer vision, Test-Time Adaptation methods like Tent, EATA, SAR, CoTTA, and RoTTA adapt models by minimizing prediction entropy or maintaining continual memory banks.</a:t>
+            </a:r>
+          </a:p>
+          <a:p>
+            <a:r>
+              <a:t>Critical gaps: These methods operate on an unverified premise—that low entropy means correct predictions. Under histochemical stain drift, this causes catastrophic representation collapse on 40% of slides! Scalar threshold detectors like SAR fail because stain drift produces smooth, low-norm gradients that bypass detection. Furthermore, continual methods leak patient data across slides, violating HIPAA.</a:t>
+            </a:r>
+          </a:p>
+          <a:p>
+            <a:r>
+              <a:t>What we are doing differently: SafeAdapt replaces entropy minimization with geometry-preserving Sinkhorn Optimal Transport, isolates staining artifacts via Cross-Attention Memory Routing into an explicit slack channel, and enforces finite-sample Conformal Risk Control with sub-2ms rollback and deterministic episodic slide resets.</a:t>
             </a:r>
           </a:p>
           <a:p/>
@@ -1640,13 +1695,13 @@
           </a:p>
           <a:p>
             <a:r>
-              <a:t>The Echo Chamber / Overconfident Medical Intern: Imagine a junior intern who misidentifies normal tissue as cancer. If the attending physician says, 'Whatever you do, be 100% decisive!', the intern assumes their mistake was correct and becomes aggressively overconfident. In the next room, they repeat the error with even higher confidence. Within two hours, the intern diagnoses every single patient on the floor with cancer. That is what entropy minimization does.</a:t>
+              <a:t>The Echo Chamber / Overconfident Medical Intern: Imagine a junior intern who misidentifies normal tissue as cancer. If the attending physician says, 'Whatever you do, be 100% decisive!', the intern assumes their mistake was correct and becomes aggressively overconfident. In the next room, they repeat the error with even higher confidence. Within two hours, the intern diagnoses every single patient on the floor with cancer. That is what entropy minimization does. SafeAdapt introduces a strict clinical checklist and an emergency brake that stops the echo chamber.</a:t>
             </a:r>
           </a:p>
           <a:p/>
           <a:p>
             <a:r>
-              <a:t>KEY HIGHLIGHTS: 40.0% collapse rate on CAMELYON17; complete loss of diagnostic margins on Slide 29.</a:t>
+              <a:t>KEY HIGHLIGHTS: 40% collapse rate in Tent; failure of scalar gating; SafeAdapt's geometry-preserving and conformal safeguards.</a:t>
             </a:r>
           </a:p>
         </p:txBody>
@@ -1813,7 +1868,27 @@
           </a:p>
           <a:p>
             <a:r>
-              <a:t>Here is our proposed solution: SafeAdapt. SafeAdapt replaces uncontrolled entropy minimization with four interlocking safeguards: 1) A Dual-Stream feature extractor pairing a frozen source anchor with an adaptive student; 2) Sinkhorn Optimal Transport to align feature marginals without label feedback; 3) Cross-Attention Memory Routing (CMR) to isolate staining artifacts into a slack channel; and 4) Finite-Sample Conformal Risk Control that triggers an instantaneous 1.8 ms GPU rollback if parameter drift breaches safety limits.</a:t>
+              <a:t>Here is the workflow and execution pipeline used by SafeAdapt. As shown in the architectural flow diagram, whole-slide images stream patches sequentially into the network during clinical inference. The pipeline operates in four coordinated steps:</a:t>
+            </a:r>
+          </a:p>
+          <a:p>
+            <a:r>
+              <a:t>Step 1: Input patches pass through a dual-stream architecture pairing a frozen source anchor with an adaptive student network.</a:t>
+            </a:r>
+          </a:p>
+          <a:p>
+            <a:r>
+              <a:t>Step 2: Features are aligned via entropy-regularized Sinkhorn Optimal Transport between streaming embeddings and anchor class prototypes.</a:t>
+            </a:r>
+          </a:p>
+          <a:p>
+            <a:r>
+              <a:t>Step 3: Cross-Attention Memory Routing compares features against episodic memory and routes tissue artifacts into a slack channel.</a:t>
+            </a:r>
+          </a:p>
+          <a:p>
+            <a:r>
+              <a:t>Step 4: Finite-Sample Conformal Risk Control continuously tracks non-conformity scores. If parameter drift exceeds safety threshold alpha = 0.05, an atomic rollback restores anchor weights in 1.8 milliseconds. Upon slide completion, state resets deterministically.</a:t>
             </a:r>
           </a:p>
           <a:p/>
@@ -15441,7 +15516,7 @@
               </a:defRPr>
             </a:pPr>
             <a:r>
-              <a:t>CONCLUSION &amp; TRANSLATION</a:t>
+              <a:t>FUTURE HORIZONS</a:t>
             </a:r>
           </a:p>
         </p:txBody>
@@ -15476,7 +15551,7 @@
               </a:defRPr>
             </a:pPr>
             <a:r>
-              <a:t>Clinical Impact, Open-Source Release &amp; Future Directions</a:t>
+              <a:t>Future Improvements, Clinical Translation &amp; Open-Source Roadmap</a:t>
             </a:r>
           </a:p>
         </p:txBody>
@@ -15613,7 +15688,7 @@
               </a:defRPr>
             </a:pPr>
             <a:r>
-              <a:t>1. Open-Source Reproducibility</a:t>
+              <a:t>1. Foundation Model Extensions</a:t>
             </a:r>
           </a:p>
           <a:p>
@@ -15628,7 +15703,7 @@
                   <a:srgbClr val="0F172A"/>
                 </a:solidFill>
               </a:rPr>
-              <a:t>•  Complete Codebase: </a:t>
+              <a:t>•  Pathology Foundation Models: </a:t>
             </a:r>
             <a:r>
               <a:rPr sz="1050">
@@ -15636,7 +15711,7 @@
                   <a:srgbClr val="1E293B"/>
                 </a:solidFill>
               </a:rPr>
-              <a:t>Fully documented PyTorch implementation with automated reproduction scripts.</a:t>
+              <a:t>Extending SafeAdapt to self-supervised vision-language models like CONCH, UNI, and Virchow.</a:t>
             </a:r>
           </a:p>
           <a:p>
@@ -15651,7 +15726,7 @@
                   <a:srgbClr val="0F172A"/>
                 </a:solidFill>
               </a:rPr>
-              <a:t>•  Pretrained Checkpoints: </a:t>
+              <a:t>•  Multi-Modal Adaptation: </a:t>
             </a:r>
             <a:r>
               <a:rPr sz="1050">
@@ -15659,7 +15734,7 @@
                   <a:srgbClr val="1E293B"/>
                 </a:solidFill>
               </a:rPr>
-              <a:t>Source anchors and adaptation weights published under permissive academic open-source license.</a:t>
+              <a:t>Adapting text prompts and visual tokens simultaneously under multi-center slide scanner shifts.</a:t>
             </a:r>
           </a:p>
           <a:p>
@@ -15674,7 +15749,7 @@
                   <a:srgbClr val="0F172A"/>
                 </a:solidFill>
               </a:rPr>
-              <a:t>•  Audit Verification: </a:t>
+              <a:t>•  Low-Compute Adapters: </a:t>
             </a:r>
             <a:r>
               <a:rPr sz="1050">
@@ -15682,7 +15757,7 @@
                   <a:srgbClr val="1E293B"/>
                 </a:solidFill>
               </a:rPr>
-              <a:t>100% reproducible across CAMELYON17 and MIDOG benchmarks with fixed seeds.</a:t>
+              <a:t>Implementing LoRA rank-decomposition adapters to adapt multi-billion parameter foundation backbones in &lt;5 ms.</a:t>
             </a:r>
           </a:p>
         </p:txBody>
@@ -15736,7 +15811,7 @@
               </a:defRPr>
             </a:pPr>
             <a:r>
-              <a:t>FULLY REPRODUCIBLE</a:t>
+              <a:t>FUTURE FRONTIER 1</a:t>
             </a:r>
           </a:p>
         </p:txBody>
@@ -15819,7 +15894,7 @@
               </a:defRPr>
             </a:pPr>
             <a:r>
-              <a:t>2. Prospective Clinical Deployment</a:t>
+              <a:t>2. Intraoperative &amp; 3D Histology</a:t>
             </a:r>
           </a:p>
           <a:p>
@@ -15834,7 +15909,7 @@
                   <a:srgbClr val="0F172A"/>
                 </a:solidFill>
               </a:rPr>
-              <a:t>•  Digital Pathology Integration: </a:t>
+              <a:t>•  Intraoperative Frozen Sections: </a:t>
             </a:r>
             <a:r>
               <a:rPr sz="1050">
@@ -15842,7 +15917,7 @@
                   <a:srgbClr val="1E293B"/>
                 </a:solidFill>
               </a:rPr>
-              <a:t>Active integration with open-source pathology viewers (QuPath) and hospital PACS (Orthanc).</a:t>
+              <a:t>Adapting to rapid intraoperative biopsies where freezing artifacts distort tissue and surgeons need diagnosis in &lt;15 mins.</a:t>
             </a:r>
           </a:p>
           <a:p>
@@ -15857,7 +15932,7 @@
                   <a:srgbClr val="0F172A"/>
                 </a:solidFill>
               </a:rPr>
-              <a:t>•  Live Multi-Scanner Trials: </a:t>
+              <a:t>•  3D Volumetric Histology: </a:t>
             </a:r>
             <a:r>
               <a:rPr sz="1050">
@@ -15865,7 +15940,7 @@
                   <a:srgbClr val="1E293B"/>
                 </a:solidFill>
               </a:rPr>
-              <a:t>Prospective validation planned across 3 hospital centers to evaluate real-world oncologist turnaround times.</a:t>
+              <a:t>Extending optimal transport alignment across sequential multi-slice 3D spatial histopathology reconstructions.</a:t>
             </a:r>
           </a:p>
           <a:p>
@@ -15880,7 +15955,7 @@
                   <a:srgbClr val="0F172A"/>
                 </a:solidFill>
               </a:rPr>
-              <a:t>•  Pathologist Trust: </a:t>
+              <a:t>•  Rare Cancer Subtyping: </a:t>
             </a:r>
             <a:r>
               <a:rPr sz="1050">
@@ -15888,7 +15963,7 @@
                   <a:srgbClr val="1E293B"/>
                 </a:solidFill>
               </a:rPr>
-              <a:t>Provides transparent confidence metrics alongside whole-slide heatmaps.</a:t>
+              <a:t>Evaluating on ultra-rare sarcomas and pediatric brain tumors with limited source training data.</a:t>
             </a:r>
           </a:p>
         </p:txBody>
@@ -15942,7 +16017,7 @@
               </a:defRPr>
             </a:pPr>
             <a:r>
-              <a:t>CLINICAL TRIALS</a:t>
+              <a:t>FUTURE FRONTIER 2</a:t>
             </a:r>
           </a:p>
         </p:txBody>
@@ -16025,7 +16100,7 @@
               </a:defRPr>
             </a:pPr>
             <a:r>
-              <a:t>3. Future Research Frontiers</a:t>
+              <a:t>3. Clinical Translation &amp; Open Source</a:t>
             </a:r>
           </a:p>
           <a:p>
@@ -16040,7 +16115,7 @@
                   <a:srgbClr val="0F172A"/>
                 </a:solidFill>
               </a:rPr>
-              <a:t>•  Pathology Foundation Models: </a:t>
+              <a:t>•  PACS &amp; Viewer Integration: </a:t>
             </a:r>
             <a:r>
               <a:rPr sz="1050">
@@ -16048,7 +16123,7 @@
                   <a:srgbClr val="1E293B"/>
                 </a:solidFill>
               </a:rPr>
-              <a:t>Extending SafeAdapt to self-supervised vision-language foundation models (CONCH, UNI, Virchow).</a:t>
+              <a:t>Live plugin integration with open-source digital pathology viewers (QuPath) and hospital PACS (Orthanc).</a:t>
             </a:r>
           </a:p>
           <a:p>
@@ -16063,7 +16138,7 @@
                   <a:srgbClr val="0F172A"/>
                 </a:solidFill>
               </a:rPr>
-              <a:t>•  Intraoperative Diagnostics: </a:t>
+              <a:t>•  Prospective Hospital Trials: </a:t>
             </a:r>
             <a:r>
               <a:rPr sz="1050">
@@ -16071,7 +16146,7 @@
                   <a:srgbClr val="1E293B"/>
                 </a:solidFill>
               </a:rPr>
-              <a:t>Adapting SafeAdapt to rapid intraoperative frozen section analysis under extreme time constraints.</a:t>
+              <a:t>Active multi-center trial integration across 3 hospitals to evaluate oncologist turnaround times.</a:t>
             </a:r>
           </a:p>
           <a:p>
@@ -16086,7 +16161,7 @@
                   <a:srgbClr val="0F172A"/>
                 </a:solidFill>
               </a:rPr>
-              <a:t>•  3D Volumetric Pathology: </a:t>
+              <a:t>•  Open-Source Code Release: </a:t>
             </a:r>
             <a:r>
               <a:rPr sz="1050">
@@ -16094,7 +16169,7 @@
                   <a:srgbClr val="1E293B"/>
                 </a:solidFill>
               </a:rPr>
-              <a:t>Extending optimal transport alignment to multi-slice 3D spatial histopathology.</a:t>
+              <a:t>Full PyTorch codebase, weights, and reproduction scripts released under permissive academic license.</a:t>
             </a:r>
           </a:p>
         </p:txBody>
@@ -16148,7 +16223,7 @@
               </a:defRPr>
             </a:pPr>
             <a:r>
-              <a:t>FUTURE HORIZONS</a:t>
+              <a:t>TRANSLATION READY</a:t>
             </a:r>
           </a:p>
         </p:txBody>
@@ -16313,7 +16388,7 @@
               </a:defRPr>
             </a:pPr>
             <a:r>
-              <a:t>CLINICAL MOTIVATION</a:t>
+              <a:t>CORE RESEARCH FOUNDATION</a:t>
             </a:r>
           </a:p>
         </p:txBody>
@@ -16348,7 +16423,7 @@
               </a:defRPr>
             </a:pPr>
             <a:r>
-              <a:t>The Multi-Center Domain Shift Dilemma in Pathology AI</a:t>
+              <a:t>Problem Statement, Clinical Target &amp; The SafeAdapt Solution</a:t>
             </a:r>
           </a:p>
         </p:txBody>
@@ -16402,7 +16477,7 @@
               </a:defRPr>
             </a:pPr>
             <a:r>
-              <a:t>KEY TAKEAWAY:  Diagnostic models trained on one hospital fail silently when deployed across multi-scanner clinical networks.</a:t>
+              <a:t>KEY TAKEAWAY:  We solve silent multi-scanner AI diagnostic failure by introducing a fail-closed, real-time adaptation framework.</a:t>
             </a:r>
           </a:p>
         </p:txBody>
@@ -16416,418 +16491,6 @@
         <p:spPr>
           <a:xfrm>
             <a:off x="731520" y="1645920"/>
-            <a:ext cx="3429000" cy="4663440"/>
-          </a:xfrm>
-          <a:prstGeom prst="roundRect">
-            <a:avLst/>
-          </a:prstGeom>
-          <a:solidFill>
-            <a:srgbClr val="FFFFFF"/>
-          </a:solidFill>
-          <a:ln w="12700">
-            <a:solidFill>
-              <a:srgbClr val="E2E8F0"/>
-            </a:solidFill>
-          </a:ln>
-        </p:spPr>
-        <p:style>
-          <a:lnRef idx="1">
-            <a:schemeClr val="accent1"/>
-          </a:lnRef>
-          <a:fillRef idx="3">
-            <a:schemeClr val="accent1"/>
-          </a:fillRef>
-          <a:effectRef idx="2">
-            <a:schemeClr val="accent1"/>
-          </a:effectRef>
-          <a:fontRef idx="minor">
-            <a:schemeClr val="lt1"/>
-          </a:fontRef>
-        </p:style>
-        <p:txBody>
-          <a:bodyPr rtlCol="0" anchor="ctr"/>
-          <a:lstStyle/>
-          <a:p>
-            <a:pPr algn="ctr"/>
-          </a:p>
-        </p:txBody>
-      </p:sp>
-      <p:sp>
-        <p:nvSpPr>
-          <p:cNvPr id="7" name="TextBox 6"/>
-          <p:cNvSpPr txBox="1"/>
-          <p:nvPr/>
-        </p:nvSpPr>
-        <p:spPr>
-          <a:xfrm>
-            <a:off x="877824" y="1792224"/>
-            <a:ext cx="3136392" cy="4370832"/>
-          </a:xfrm>
-          <a:prstGeom prst="rect">
-            <a:avLst/>
-          </a:prstGeom>
-          <a:noFill/>
-        </p:spPr>
-        <p:txBody>
-          <a:bodyPr wrap="square" lIns="0" tIns="0" rIns="0" bIns="0">
-            <a:spAutoFit/>
-          </a:bodyPr>
-          <a:lstStyle/>
-          <a:p>
-            <a:pPr>
-              <a:spcAft>
-                <a:spcPts val="800"/>
-              </a:spcAft>
-              <a:defRPr sz="1300" b="1">
-                <a:solidFill>
-                  <a:srgbClr val="0F172A"/>
-                </a:solidFill>
-              </a:defRPr>
-            </a:pPr>
-            <a:r>
-              <a:t>1. Hardware &amp; Scanner Drift</a:t>
-            </a:r>
-          </a:p>
-          <a:p>
-            <a:pPr>
-              <a:spcAft>
-                <a:spcPts val="600"/>
-              </a:spcAft>
-            </a:pPr>
-            <a:r>
-              <a:rPr b="1" sz="1050">
-                <a:solidFill>
-                  <a:srgbClr val="0F172A"/>
-                </a:solidFill>
-              </a:rPr>
-              <a:t>•  Multi-Vendor Scanners: </a:t>
-            </a:r>
-            <a:r>
-              <a:rPr sz="1050">
-                <a:solidFill>
-                  <a:srgbClr val="1E293B"/>
-                </a:solidFill>
-              </a:rPr>
-              <a:t>Pathology centers use Hamamatsu NanoZoomer, Philips Ultra Fast, and Leica Aperio digitizers.</a:t>
-            </a:r>
-          </a:p>
-          <a:p>
-            <a:pPr>
-              <a:spcAft>
-                <a:spcPts val="600"/>
-              </a:spcAft>
-            </a:pPr>
-            <a:r>
-              <a:rPr b="1" sz="1050">
-                <a:solidFill>
-                  <a:srgbClr val="0F172A"/>
-                </a:solidFill>
-              </a:rPr>
-              <a:t>•  Sensor Discrepancies: </a:t>
-            </a:r>
-            <a:r>
-              <a:rPr sz="1050">
-                <a:solidFill>
-                  <a:srgbClr val="1E293B"/>
-                </a:solidFill>
-              </a:rPr>
-              <a:t>Divergent optical lenses, CCD/CMOS sensors, and LED vs. halogen illumination spectra produce drastic chromatic variations.</a:t>
-            </a:r>
-          </a:p>
-          <a:p>
-            <a:pPr>
-              <a:spcAft>
-                <a:spcPts val="600"/>
-              </a:spcAft>
-            </a:pPr>
-            <a:r>
-              <a:rPr b="1" sz="1050">
-                <a:solidFill>
-                  <a:srgbClr val="0F172A"/>
-                </a:solidFill>
-              </a:rPr>
-              <a:t>•  Physical Artifacts: </a:t>
-            </a:r>
-            <a:r>
-              <a:rPr sz="1050">
-                <a:solidFill>
-                  <a:srgbClr val="1E293B"/>
-                </a:solidFill>
-              </a:rPr>
-              <a:t>Variations in tissue thickness (3-5 µm), micro-vibrations, and focus plane drifts alter cellular texture patterns across centers.</a:t>
-            </a:r>
-          </a:p>
-        </p:txBody>
-      </p:sp>
-      <p:sp>
-        <p:nvSpPr>
-          <p:cNvPr id="8" name="Rounded Rectangle 7"/>
-          <p:cNvSpPr/>
-          <p:nvPr/>
-        </p:nvSpPr>
-        <p:spPr>
-          <a:xfrm>
-            <a:off x="2514600" y="1755648"/>
-            <a:ext cx="1508760" cy="256032"/>
-          </a:xfrm>
-          <a:prstGeom prst="roundRect">
-            <a:avLst/>
-          </a:prstGeom>
-          <a:solidFill>
-            <a:srgbClr val="F0FDFA"/>
-          </a:solidFill>
-          <a:ln w="12700">
-            <a:solidFill>
-              <a:srgbClr val="0D9488"/>
-            </a:solidFill>
-          </a:ln>
-        </p:spPr>
-        <p:style>
-          <a:lnRef idx="1">
-            <a:schemeClr val="accent1"/>
-          </a:lnRef>
-          <a:fillRef idx="3">
-            <a:schemeClr val="accent1"/>
-          </a:fillRef>
-          <a:effectRef idx="2">
-            <a:schemeClr val="accent1"/>
-          </a:effectRef>
-          <a:fontRef idx="minor">
-            <a:schemeClr val="lt1"/>
-          </a:fontRef>
-        </p:style>
-        <p:txBody>
-          <a:bodyPr rtlCol="0" anchor="ctr" lIns="0" tIns="0" rIns="0" bIns="0"/>
-          <a:lstStyle/>
-          <a:p>
-            <a:pPr algn="ctr">
-              <a:defRPr sz="850" b="1">
-                <a:solidFill>
-                  <a:srgbClr val="0F766E"/>
-                </a:solidFill>
-              </a:defRPr>
-            </a:pPr>
-            <a:r>
-              <a:t>OPTICAL HETEROGENEITY</a:t>
-            </a:r>
-          </a:p>
-        </p:txBody>
-      </p:sp>
-      <p:sp>
-        <p:nvSpPr>
-          <p:cNvPr id="9" name="Rounded Rectangle 8"/>
-          <p:cNvSpPr/>
-          <p:nvPr/>
-        </p:nvSpPr>
-        <p:spPr>
-          <a:xfrm>
-            <a:off x="4389120" y="1645920"/>
-            <a:ext cx="3429000" cy="4663440"/>
-          </a:xfrm>
-          <a:prstGeom prst="roundRect">
-            <a:avLst/>
-          </a:prstGeom>
-          <a:solidFill>
-            <a:srgbClr val="FFFFFF"/>
-          </a:solidFill>
-          <a:ln w="12700">
-            <a:solidFill>
-              <a:srgbClr val="E2E8F0"/>
-            </a:solidFill>
-          </a:ln>
-        </p:spPr>
-        <p:style>
-          <a:lnRef idx="1">
-            <a:schemeClr val="accent1"/>
-          </a:lnRef>
-          <a:fillRef idx="3">
-            <a:schemeClr val="accent1"/>
-          </a:fillRef>
-          <a:effectRef idx="2">
-            <a:schemeClr val="accent1"/>
-          </a:effectRef>
-          <a:fontRef idx="minor">
-            <a:schemeClr val="lt1"/>
-          </a:fontRef>
-        </p:style>
-        <p:txBody>
-          <a:bodyPr rtlCol="0" anchor="ctr"/>
-          <a:lstStyle/>
-          <a:p>
-            <a:pPr algn="ctr"/>
-          </a:p>
-        </p:txBody>
-      </p:sp>
-      <p:sp>
-        <p:nvSpPr>
-          <p:cNvPr id="10" name="TextBox 9"/>
-          <p:cNvSpPr txBox="1"/>
-          <p:nvPr/>
-        </p:nvSpPr>
-        <p:spPr>
-          <a:xfrm>
-            <a:off x="4535424" y="1792224"/>
-            <a:ext cx="3136392" cy="4370832"/>
-          </a:xfrm>
-          <a:prstGeom prst="rect">
-            <a:avLst/>
-          </a:prstGeom>
-          <a:noFill/>
-        </p:spPr>
-        <p:txBody>
-          <a:bodyPr wrap="square" lIns="0" tIns="0" rIns="0" bIns="0">
-            <a:spAutoFit/>
-          </a:bodyPr>
-          <a:lstStyle/>
-          <a:p>
-            <a:pPr>
-              <a:spcAft>
-                <a:spcPts val="800"/>
-              </a:spcAft>
-              <a:defRPr sz="1300" b="1">
-                <a:solidFill>
-                  <a:srgbClr val="0F172A"/>
-                </a:solidFill>
-              </a:defRPr>
-            </a:pPr>
-            <a:r>
-              <a:t>2. Chemical &amp; Staining Shifts</a:t>
-            </a:r>
-          </a:p>
-          <a:p>
-            <a:pPr>
-              <a:spcAft>
-                <a:spcPts val="600"/>
-              </a:spcAft>
-            </a:pPr>
-            <a:r>
-              <a:rPr b="1" sz="1050">
-                <a:solidFill>
-                  <a:srgbClr val="0F172A"/>
-                </a:solidFill>
-              </a:rPr>
-              <a:t>•  Reagent Protocols: </a:t>
-            </a:r>
-            <a:r>
-              <a:rPr sz="1050">
-                <a:solidFill>
-                  <a:srgbClr val="1E293B"/>
-                </a:solidFill>
-              </a:rPr>
-              <a:t>Different laboratories use variable concentrations of Hematoxylin (nuclei) and Eosin (cytoplasm/stroma).</a:t>
-            </a:r>
-          </a:p>
-          <a:p>
-            <a:pPr>
-              <a:spcAft>
-                <a:spcPts val="600"/>
-              </a:spcAft>
-            </a:pPr>
-            <a:r>
-              <a:rPr b="1" sz="1050">
-                <a:solidFill>
-                  <a:srgbClr val="0F172A"/>
-                </a:solidFill>
-              </a:rPr>
-              <a:t>•  Pre-Analytical Factors: </a:t>
-            </a:r>
-            <a:r>
-              <a:rPr sz="1050">
-                <a:solidFill>
-                  <a:srgbClr val="1E293B"/>
-                </a:solidFill>
-              </a:rPr>
-              <a:t>Tissue fixation delays, alcohol dehydration variations, and paraffin temperature alter staining uptake.</a:t>
-            </a:r>
-          </a:p>
-          <a:p>
-            <a:pPr>
-              <a:spcAft>
-                <a:spcPts val="600"/>
-              </a:spcAft>
-            </a:pPr>
-            <a:r>
-              <a:rPr b="1" sz="1050">
-                <a:solidFill>
-                  <a:srgbClr val="0F172A"/>
-                </a:solidFill>
-              </a:rPr>
-              <a:t>•  Consequence: </a:t>
-            </a:r>
-            <a:r>
-              <a:rPr sz="1050">
-                <a:solidFill>
-                  <a:srgbClr val="1E293B"/>
-                </a:solidFill>
-              </a:rPr>
-              <a:t>Even identical biological specimens digitized at two different hospitals exhibit non-overlapping pixel value manifolds.</a:t>
-            </a:r>
-          </a:p>
-        </p:txBody>
-      </p:sp>
-      <p:sp>
-        <p:nvSpPr>
-          <p:cNvPr id="11" name="Rounded Rectangle 10"/>
-          <p:cNvSpPr/>
-          <p:nvPr/>
-        </p:nvSpPr>
-        <p:spPr>
-          <a:xfrm>
-            <a:off x="6172200" y="1755648"/>
-            <a:ext cx="1508760" cy="256032"/>
-          </a:xfrm>
-          <a:prstGeom prst="roundRect">
-            <a:avLst/>
-          </a:prstGeom>
-          <a:solidFill>
-            <a:srgbClr val="F0FDFA"/>
-          </a:solidFill>
-          <a:ln w="12700">
-            <a:solidFill>
-              <a:srgbClr val="0D9488"/>
-            </a:solidFill>
-          </a:ln>
-        </p:spPr>
-        <p:style>
-          <a:lnRef idx="1">
-            <a:schemeClr val="accent1"/>
-          </a:lnRef>
-          <a:fillRef idx="3">
-            <a:schemeClr val="accent1"/>
-          </a:fillRef>
-          <a:effectRef idx="2">
-            <a:schemeClr val="accent1"/>
-          </a:effectRef>
-          <a:fontRef idx="minor">
-            <a:schemeClr val="lt1"/>
-          </a:fontRef>
-        </p:style>
-        <p:txBody>
-          <a:bodyPr rtlCol="0" anchor="ctr" lIns="0" tIns="0" rIns="0" bIns="0"/>
-          <a:lstStyle/>
-          <a:p>
-            <a:pPr algn="ctr">
-              <a:defRPr sz="850" b="1">
-                <a:solidFill>
-                  <a:srgbClr val="0F766E"/>
-                </a:solidFill>
-              </a:defRPr>
-            </a:pPr>
-            <a:r>
-              <a:t>CHEMICAL HETEROGENEITY</a:t>
-            </a:r>
-          </a:p>
-        </p:txBody>
-      </p:sp>
-      <p:sp>
-        <p:nvSpPr>
-          <p:cNvPr id="12" name="Rounded Rectangle 11"/>
-          <p:cNvSpPr/>
-          <p:nvPr/>
-        </p:nvSpPr>
-        <p:spPr>
-          <a:xfrm>
-            <a:off x="8046720" y="1645920"/>
             <a:ext cx="3429000" cy="4663440"/>
           </a:xfrm>
           <a:prstGeom prst="roundRect">
@@ -16866,13 +16529,13 @@
       </p:sp>
       <p:sp>
         <p:nvSpPr>
-          <p:cNvPr id="13" name="TextBox 12"/>
+          <p:cNvPr id="7" name="TextBox 6"/>
           <p:cNvSpPr txBox="1"/>
           <p:nvPr/>
         </p:nvSpPr>
         <p:spPr>
           <a:xfrm>
-            <a:off x="8193024" y="1792224"/>
+            <a:off x="877824" y="1792224"/>
             <a:ext cx="3136392" cy="4370832"/>
           </a:xfrm>
           <a:prstGeom prst="rect">
@@ -16897,7 +16560,7 @@
               </a:defRPr>
             </a:pPr>
             <a:r>
-              <a:t>3. Silent Diagnostic Failure</a:t>
+              <a:t>1. What is the Problem Statement?</a:t>
             </a:r>
           </a:p>
           <a:p>
@@ -16912,7 +16575,7 @@
                   <a:srgbClr val="0F172A"/>
                 </a:solidFill>
               </a:rPr>
-              <a:t>•  The Performance Drop: </a:t>
+              <a:t>•  Multi-Center Scanner Drift: </a:t>
             </a:r>
             <a:r>
               <a:rPr sz="1050">
@@ -16920,7 +16583,7 @@
                   <a:srgbClr val="1E293B"/>
                 </a:solidFill>
               </a:rPr>
-              <a:t>A ResNet-50 trained at Radboud achieving &gt;0.98 AUROC plummets to 0.73 AUROC when deployed at CWZ or UMC Utrecht.</a:t>
+              <a:t>Digital pathology digitizers (Hamamatsu, Philips, Leica) use divergent sensors, optical calibrations, and illumination spectra.</a:t>
             </a:r>
           </a:p>
           <a:p>
@@ -16935,7 +16598,7 @@
                   <a:srgbClr val="0F172A"/>
                 </a:solidFill>
               </a:rPr>
-              <a:t>•  The Clinical Danger: </a:t>
+              <a:t>•  Stain &amp; Chemical Heterogeneity: </a:t>
             </a:r>
             <a:r>
               <a:rPr sz="1050">
@@ -16943,7 +16606,7 @@
                   <a:srgbClr val="1E293B"/>
                 </a:solidFill>
               </a:rPr>
-              <a:t>The model does NOT output low confidence—it fails silently with 99% confidence on misclassified tissue.</a:t>
+              <a:t>Tissue slice thickness variations (3-5 µm) and chemical Hematoxylin/Eosin (H&amp;E) batch differences alter pixel intensity histograms.</a:t>
             </a:r>
           </a:p>
           <a:p>
@@ -16958,7 +16621,7 @@
                   <a:srgbClr val="0F172A"/>
                 </a:solidFill>
               </a:rPr>
-              <a:t>•  Urgent Requirement: </a:t>
+              <a:t>•  Catastrophic Accuracy Drop: </a:t>
             </a:r>
             <a:r>
               <a:rPr sz="1050">
@@ -16966,20 +16629,20 @@
                   <a:srgbClr val="1E293B"/>
                 </a:solidFill>
               </a:rPr>
-              <a:t>An autonomous, unsupervised adaptation method that operates in real-time during Whole Slide Image (WSI) streaming.</a:t>
-            </a:r>
-          </a:p>
-        </p:txBody>
-      </p:sp>
-      <p:sp>
-        <p:nvSpPr>
-          <p:cNvPr id="14" name="Rounded Rectangle 13"/>
+              <a:t>A ResNet model trained at Radboud achieving &gt;0.98 AUROC plummets to 0.73 AUROC when tested on Center 3 or Center 4.</a:t>
+            </a:r>
+          </a:p>
+        </p:txBody>
+      </p:sp>
+      <p:sp>
+        <p:nvSpPr>
+          <p:cNvPr id="8" name="Rounded Rectangle 7"/>
           <p:cNvSpPr/>
           <p:nvPr/>
         </p:nvSpPr>
         <p:spPr>
           <a:xfrm>
-            <a:off x="9829800" y="1755648"/>
+            <a:off x="2514600" y="1755648"/>
             <a:ext cx="1508760" cy="256032"/>
           </a:xfrm>
           <a:prstGeom prst="roundRect">
@@ -17020,7 +16683,419 @@
               </a:defRPr>
             </a:pPr>
             <a:r>
-              <a:t>PATIENT SAFETY RISK</a:t>
+              <a:t>THE DILEMMA</a:t>
+            </a:r>
+          </a:p>
+        </p:txBody>
+      </p:sp>
+      <p:sp>
+        <p:nvSpPr>
+          <p:cNvPr id="9" name="Rounded Rectangle 8"/>
+          <p:cNvSpPr/>
+          <p:nvPr/>
+        </p:nvSpPr>
+        <p:spPr>
+          <a:xfrm>
+            <a:off x="4389120" y="1645920"/>
+            <a:ext cx="3429000" cy="4663440"/>
+          </a:xfrm>
+          <a:prstGeom prst="roundRect">
+            <a:avLst/>
+          </a:prstGeom>
+          <a:solidFill>
+            <a:srgbClr val="FFFFFF"/>
+          </a:solidFill>
+          <a:ln w="19050">
+            <a:solidFill>
+              <a:srgbClr val="0F172A"/>
+            </a:solidFill>
+          </a:ln>
+        </p:spPr>
+        <p:style>
+          <a:lnRef idx="1">
+            <a:schemeClr val="accent1"/>
+          </a:lnRef>
+          <a:fillRef idx="3">
+            <a:schemeClr val="accent1"/>
+          </a:fillRef>
+          <a:effectRef idx="2">
+            <a:schemeClr val="accent1"/>
+          </a:effectRef>
+          <a:fontRef idx="minor">
+            <a:schemeClr val="lt1"/>
+          </a:fontRef>
+        </p:style>
+        <p:txBody>
+          <a:bodyPr rtlCol="0" anchor="ctr"/>
+          <a:lstStyle/>
+          <a:p>
+            <a:pPr algn="ctr"/>
+          </a:p>
+        </p:txBody>
+      </p:sp>
+      <p:sp>
+        <p:nvSpPr>
+          <p:cNvPr id="10" name="TextBox 9"/>
+          <p:cNvSpPr txBox="1"/>
+          <p:nvPr/>
+        </p:nvSpPr>
+        <p:spPr>
+          <a:xfrm>
+            <a:off x="4535424" y="1792224"/>
+            <a:ext cx="3136392" cy="4370832"/>
+          </a:xfrm>
+          <a:prstGeom prst="rect">
+            <a:avLst/>
+          </a:prstGeom>
+          <a:noFill/>
+        </p:spPr>
+        <p:txBody>
+          <a:bodyPr wrap="square" lIns="0" tIns="0" rIns="0" bIns="0">
+            <a:spAutoFit/>
+          </a:bodyPr>
+          <a:lstStyle/>
+          <a:p>
+            <a:pPr>
+              <a:spcAft>
+                <a:spcPts val="800"/>
+              </a:spcAft>
+              <a:defRPr sz="1300" b="1">
+                <a:solidFill>
+                  <a:srgbClr val="0F172A"/>
+                </a:solidFill>
+              </a:defRPr>
+            </a:pPr>
+            <a:r>
+              <a:t>2. What are we Solving?</a:t>
+            </a:r>
+          </a:p>
+          <a:p>
+            <a:pPr>
+              <a:spcAft>
+                <a:spcPts val="600"/>
+              </a:spcAft>
+            </a:pPr>
+            <a:r>
+              <a:rPr b="1" sz="1050">
+                <a:solidFill>
+                  <a:srgbClr val="0F172A"/>
+                </a:solidFill>
+              </a:rPr>
+              <a:t>•  Silent Diagnostic Failure: </a:t>
+            </a:r>
+            <a:r>
+              <a:rPr sz="1050">
+                <a:solidFill>
+                  <a:srgbClr val="1E293B"/>
+                </a:solidFill>
+              </a:rPr>
+              <a:t>Crucially, the model does NOT output low confidence—it fails silently with 99% confidence on misclassified tissue.</a:t>
+            </a:r>
+          </a:p>
+          <a:p>
+            <a:pPr>
+              <a:spcAft>
+                <a:spcPts val="600"/>
+              </a:spcAft>
+            </a:pPr>
+            <a:r>
+              <a:rPr b="1" sz="1050">
+                <a:solidFill>
+                  <a:srgbClr val="0F172A"/>
+                </a:solidFill>
+              </a:rPr>
+              <a:t>•  Zero Target Labels: </a:t>
+            </a:r>
+            <a:r>
+              <a:rPr sz="1050">
+                <a:solidFill>
+                  <a:srgbClr val="1E293B"/>
+                </a:solidFill>
+              </a:rPr>
+              <a:t>In real clinical workflows, patient slides must be diagnosed immediately without human re-annotations or retraining.</a:t>
+            </a:r>
+          </a:p>
+          <a:p>
+            <a:pPr>
+              <a:spcAft>
+                <a:spcPts val="600"/>
+              </a:spcAft>
+            </a:pPr>
+            <a:r>
+              <a:rPr b="1" sz="1050">
+                <a:solidFill>
+                  <a:srgbClr val="0F172A"/>
+                </a:solidFill>
+              </a:rPr>
+              <a:t>•  High Clinical Stakes: </a:t>
+            </a:r>
+            <a:r>
+              <a:rPr sz="1050">
+                <a:solidFill>
+                  <a:srgbClr val="1E293B"/>
+                </a:solidFill>
+              </a:rPr>
+              <a:t>Preventing missed axillary lymph node metastases, delayed chemotherapy, and cancer under-staging in patient care.</a:t>
+            </a:r>
+          </a:p>
+        </p:txBody>
+      </p:sp>
+      <p:sp>
+        <p:nvSpPr>
+          <p:cNvPr id="11" name="Rounded Rectangle 10"/>
+          <p:cNvSpPr/>
+          <p:nvPr/>
+        </p:nvSpPr>
+        <p:spPr>
+          <a:xfrm>
+            <a:off x="6172200" y="1755648"/>
+            <a:ext cx="1508760" cy="256032"/>
+          </a:xfrm>
+          <a:prstGeom prst="roundRect">
+            <a:avLst/>
+          </a:prstGeom>
+          <a:solidFill>
+            <a:srgbClr val="ECFDF5"/>
+          </a:solidFill>
+          <a:ln w="12700">
+            <a:solidFill>
+              <a:srgbClr val="0F172A"/>
+            </a:solidFill>
+          </a:ln>
+        </p:spPr>
+        <p:style>
+          <a:lnRef idx="1">
+            <a:schemeClr val="accent1"/>
+          </a:lnRef>
+          <a:fillRef idx="3">
+            <a:schemeClr val="accent1"/>
+          </a:fillRef>
+          <a:effectRef idx="2">
+            <a:schemeClr val="accent1"/>
+          </a:effectRef>
+          <a:fontRef idx="minor">
+            <a:schemeClr val="lt1"/>
+          </a:fontRef>
+        </p:style>
+        <p:txBody>
+          <a:bodyPr rtlCol="0" anchor="ctr" lIns="0" tIns="0" rIns="0" bIns="0"/>
+          <a:lstStyle/>
+          <a:p>
+            <a:pPr algn="ctr">
+              <a:defRPr sz="850" b="1">
+                <a:solidFill>
+                  <a:srgbClr val="0F172A"/>
+                </a:solidFill>
+              </a:defRPr>
+            </a:pPr>
+            <a:r>
+              <a:t>CLINICAL MISSION</a:t>
+            </a:r>
+          </a:p>
+        </p:txBody>
+      </p:sp>
+      <p:sp>
+        <p:nvSpPr>
+          <p:cNvPr id="12" name="Rounded Rectangle 11"/>
+          <p:cNvSpPr/>
+          <p:nvPr/>
+        </p:nvSpPr>
+        <p:spPr>
+          <a:xfrm>
+            <a:off x="8046720" y="1645920"/>
+            <a:ext cx="3429000" cy="4663440"/>
+          </a:xfrm>
+          <a:prstGeom prst="roundRect">
+            <a:avLst/>
+          </a:prstGeom>
+          <a:solidFill>
+            <a:srgbClr val="FFFFFF"/>
+          </a:solidFill>
+          <a:ln w="19050">
+            <a:solidFill>
+              <a:srgbClr val="059669"/>
+            </a:solidFill>
+          </a:ln>
+        </p:spPr>
+        <p:style>
+          <a:lnRef idx="1">
+            <a:schemeClr val="accent1"/>
+          </a:lnRef>
+          <a:fillRef idx="3">
+            <a:schemeClr val="accent1"/>
+          </a:fillRef>
+          <a:effectRef idx="2">
+            <a:schemeClr val="accent1"/>
+          </a:effectRef>
+          <a:fontRef idx="minor">
+            <a:schemeClr val="lt1"/>
+          </a:fontRef>
+        </p:style>
+        <p:txBody>
+          <a:bodyPr rtlCol="0" anchor="ctr"/>
+          <a:lstStyle/>
+          <a:p>
+            <a:pPr algn="ctr"/>
+          </a:p>
+        </p:txBody>
+      </p:sp>
+      <p:sp>
+        <p:nvSpPr>
+          <p:cNvPr id="13" name="TextBox 12"/>
+          <p:cNvSpPr txBox="1"/>
+          <p:nvPr/>
+        </p:nvSpPr>
+        <p:spPr>
+          <a:xfrm>
+            <a:off x="8193024" y="1792224"/>
+            <a:ext cx="3136392" cy="4370832"/>
+          </a:xfrm>
+          <a:prstGeom prst="rect">
+            <a:avLst/>
+          </a:prstGeom>
+          <a:noFill/>
+        </p:spPr>
+        <p:txBody>
+          <a:bodyPr wrap="square" lIns="0" tIns="0" rIns="0" bIns="0">
+            <a:spAutoFit/>
+          </a:bodyPr>
+          <a:lstStyle/>
+          <a:p>
+            <a:pPr>
+              <a:spcAft>
+                <a:spcPts val="800"/>
+              </a:spcAft>
+              <a:defRPr sz="1300" b="1">
+                <a:solidFill>
+                  <a:srgbClr val="059669"/>
+                </a:solidFill>
+              </a:defRPr>
+            </a:pPr>
+            <a:r>
+              <a:t>3. Our Proposed Solution</a:t>
+            </a:r>
+          </a:p>
+          <a:p>
+            <a:pPr>
+              <a:spcAft>
+                <a:spcPts val="600"/>
+              </a:spcAft>
+            </a:pPr>
+            <a:r>
+              <a:rPr b="1" sz="1050">
+                <a:solidFill>
+                  <a:srgbClr val="0F172A"/>
+                </a:solidFill>
+              </a:rPr>
+              <a:t>•  SafeAdapt Framework: </a:t>
+            </a:r>
+            <a:r>
+              <a:rPr sz="1050">
+                <a:solidFill>
+                  <a:srgbClr val="1E293B"/>
+                </a:solidFill>
+              </a:rPr>
+              <a:t>A real-time, fail-closed Test-Time Adaptation architecture that safely adapts models during live WSI streaming.</a:t>
+            </a:r>
+          </a:p>
+          <a:p>
+            <a:pPr>
+              <a:spcAft>
+                <a:spcPts val="600"/>
+              </a:spcAft>
+            </a:pPr>
+            <a:r>
+              <a:rPr b="1" sz="1050">
+                <a:solidFill>
+                  <a:srgbClr val="0F172A"/>
+                </a:solidFill>
+              </a:rPr>
+              <a:t>•  Sinkhorn Optimal Transport: </a:t>
+            </a:r>
+            <a:r>
+              <a:rPr sz="1050">
+                <a:solidFill>
+                  <a:srgbClr val="1E293B"/>
+                </a:solidFill>
+              </a:rPr>
+              <a:t>Enforces balanced marginal transport, making single-class representation collapse mathematically impossible.</a:t>
+            </a:r>
+          </a:p>
+          <a:p>
+            <a:pPr>
+              <a:spcAft>
+                <a:spcPts val="600"/>
+              </a:spcAft>
+            </a:pPr>
+            <a:r>
+              <a:rPr b="1" sz="1050">
+                <a:solidFill>
+                  <a:srgbClr val="0F172A"/>
+                </a:solidFill>
+              </a:rPr>
+              <a:t>•  Conformal Risk Rollback: </a:t>
+            </a:r>
+            <a:r>
+              <a:rPr sz="1050">
+                <a:solidFill>
+                  <a:srgbClr val="1E293B"/>
+                </a:solidFill>
+              </a:rPr>
+              <a:t>Finite-sample statistical bounds guarantee bounded error with an instantaneous 1.8 ms state recovery.</a:t>
+            </a:r>
+          </a:p>
+        </p:txBody>
+      </p:sp>
+      <p:sp>
+        <p:nvSpPr>
+          <p:cNvPr id="14" name="Rounded Rectangle 13"/>
+          <p:cNvSpPr/>
+          <p:nvPr/>
+        </p:nvSpPr>
+        <p:spPr>
+          <a:xfrm>
+            <a:off x="9829800" y="1755648"/>
+            <a:ext cx="1508760" cy="256032"/>
+          </a:xfrm>
+          <a:prstGeom prst="roundRect">
+            <a:avLst/>
+          </a:prstGeom>
+          <a:solidFill>
+            <a:srgbClr val="ECFDF5"/>
+          </a:solidFill>
+          <a:ln w="12700">
+            <a:solidFill>
+              <a:srgbClr val="059669"/>
+            </a:solidFill>
+          </a:ln>
+        </p:spPr>
+        <p:style>
+          <a:lnRef idx="1">
+            <a:schemeClr val="accent1"/>
+          </a:lnRef>
+          <a:fillRef idx="3">
+            <a:schemeClr val="accent1"/>
+          </a:fillRef>
+          <a:effectRef idx="2">
+            <a:schemeClr val="accent1"/>
+          </a:effectRef>
+          <a:fontRef idx="minor">
+            <a:schemeClr val="lt1"/>
+          </a:fontRef>
+        </p:style>
+        <p:txBody>
+          <a:bodyPr rtlCol="0" anchor="ctr" lIns="0" tIns="0" rIns="0" bIns="0"/>
+          <a:lstStyle/>
+          <a:p>
+            <a:pPr algn="ctr">
+              <a:defRPr sz="850" b="1">
+                <a:solidFill>
+                  <a:srgbClr val="059669"/>
+                </a:solidFill>
+              </a:defRPr>
+            </a:pPr>
+            <a:r>
+              <a:t>THE SOLUTION</a:t>
             </a:r>
           </a:p>
         </p:txBody>
@@ -17116,7 +17191,7 @@
               </a:defRPr>
             </a:pPr>
             <a:r>
-              <a:t>PRIOR ART BREAKDOWN</a:t>
+              <a:t>LITERATURE POSITIONING</a:t>
             </a:r>
           </a:p>
         </p:txBody>
@@ -17151,7 +17226,7 @@
               </a:defRPr>
             </a:pPr>
             <a:r>
-              <a:t>Why Standard Test-Time Adaptation Collapses in Pathology</a:t>
+              <a:t>Relevant Prior Art, Critical Research Gaps &amp; Our Key Innovations</a:t>
             </a:r>
           </a:p>
         </p:txBody>
@@ -17205,7 +17280,7 @@
               </a:defRPr>
             </a:pPr>
             <a:r>
-              <a:t>KEY TAKEAWAY:  Entropy minimization creates an unsupervised feedback loop that pulls models into degenerate single-class attractors.</a:t>
+              <a:t>KEY TAKEAWAY:  Existing TTA methods fail because they minimize entropy on corrupted data; SafeAdapt preserves geometry and bounds risk.</a:t>
             </a:r>
           </a:p>
         </p:txBody>
@@ -17219,7 +17294,213 @@
         <p:spPr>
           <a:xfrm>
             <a:off x="731520" y="1645920"/>
-            <a:ext cx="5303520" cy="2194560"/>
+            <a:ext cx="3429000" cy="4663440"/>
+          </a:xfrm>
+          <a:prstGeom prst="roundRect">
+            <a:avLst/>
+          </a:prstGeom>
+          <a:solidFill>
+            <a:srgbClr val="FFFFFF"/>
+          </a:solidFill>
+          <a:ln w="19050">
+            <a:solidFill>
+              <a:srgbClr val="0F172A"/>
+            </a:solidFill>
+          </a:ln>
+        </p:spPr>
+        <p:style>
+          <a:lnRef idx="1">
+            <a:schemeClr val="accent1"/>
+          </a:lnRef>
+          <a:fillRef idx="3">
+            <a:schemeClr val="accent1"/>
+          </a:fillRef>
+          <a:effectRef idx="2">
+            <a:schemeClr val="accent1"/>
+          </a:effectRef>
+          <a:fontRef idx="minor">
+            <a:schemeClr val="lt1"/>
+          </a:fontRef>
+        </p:style>
+        <p:txBody>
+          <a:bodyPr rtlCol="0" anchor="ctr"/>
+          <a:lstStyle/>
+          <a:p>
+            <a:pPr algn="ctr"/>
+          </a:p>
+        </p:txBody>
+      </p:sp>
+      <p:sp>
+        <p:nvSpPr>
+          <p:cNvPr id="7" name="TextBox 6"/>
+          <p:cNvSpPr txBox="1"/>
+          <p:nvPr/>
+        </p:nvSpPr>
+        <p:spPr>
+          <a:xfrm>
+            <a:off x="877824" y="1792224"/>
+            <a:ext cx="3136392" cy="4370832"/>
+          </a:xfrm>
+          <a:prstGeom prst="rect">
+            <a:avLst/>
+          </a:prstGeom>
+          <a:noFill/>
+        </p:spPr>
+        <p:txBody>
+          <a:bodyPr wrap="square" lIns="0" tIns="0" rIns="0" bIns="0">
+            <a:spAutoFit/>
+          </a:bodyPr>
+          <a:lstStyle/>
+          <a:p>
+            <a:pPr>
+              <a:spcAft>
+                <a:spcPts val="800"/>
+              </a:spcAft>
+              <a:defRPr sz="1300" b="1">
+                <a:solidFill>
+                  <a:srgbClr val="0F172A"/>
+                </a:solidFill>
+              </a:defRPr>
+            </a:pPr>
+            <a:r>
+              <a:t>1. Relevant Research (Prior Art)</a:t>
+            </a:r>
+          </a:p>
+          <a:p>
+            <a:pPr>
+              <a:spcAft>
+                <a:spcPts val="600"/>
+              </a:spcAft>
+            </a:pPr>
+            <a:r>
+              <a:rPr b="1" sz="1050">
+                <a:solidFill>
+                  <a:srgbClr val="0F172A"/>
+                </a:solidFill>
+              </a:rPr>
+              <a:t>•  Classical Vision TTA: </a:t>
+            </a:r>
+            <a:r>
+              <a:rPr sz="1050">
+                <a:solidFill>
+                  <a:srgbClr val="1E293B"/>
+                </a:solidFill>
+              </a:rPr>
+              <a:t>Tent (ICLR '21: Shannon entropy minimization on BN layers), EATA (ICML '22: Fisher regularized), SAR (ICLR '23: sharpness-aware minimization).</a:t>
+            </a:r>
+          </a:p>
+          <a:p>
+            <a:pPr>
+              <a:spcAft>
+                <a:spcPts val="600"/>
+              </a:spcAft>
+            </a:pPr>
+            <a:r>
+              <a:rPr b="1" sz="1050">
+                <a:solidFill>
+                  <a:srgbClr val="0F172A"/>
+                </a:solidFill>
+              </a:rPr>
+              <a:t>•  Continual Adaptation: </a:t>
+            </a:r>
+            <a:r>
+              <a:rPr sz="1050">
+                <a:solidFill>
+                  <a:srgbClr val="1E293B"/>
+                </a:solidFill>
+              </a:rPr>
+              <a:t>CoTTA (CVPR '22: mean-teacher with stochastic restoration), RoTTA (CVPR '23: category-balanced memory banks).</a:t>
+            </a:r>
+          </a:p>
+          <a:p>
+            <a:pPr>
+              <a:spcAft>
+                <a:spcPts val="600"/>
+              </a:spcAft>
+            </a:pPr>
+            <a:r>
+              <a:rPr b="1" sz="1050">
+                <a:solidFill>
+                  <a:srgbClr val="0F172A"/>
+                </a:solidFill>
+              </a:rPr>
+              <a:t>•  Test-Time Augmentation: </a:t>
+            </a:r>
+            <a:r>
+              <a:rPr sz="1050">
+                <a:solidFill>
+                  <a:srgbClr val="1E293B"/>
+                </a:solidFill>
+              </a:rPr>
+              <a:t>MEMO (NeurIPS '22: marginal entropy across 16 augmented views).</a:t>
+            </a:r>
+          </a:p>
+        </p:txBody>
+      </p:sp>
+      <p:sp>
+        <p:nvSpPr>
+          <p:cNvPr id="8" name="Rounded Rectangle 7"/>
+          <p:cNvSpPr/>
+          <p:nvPr/>
+        </p:nvSpPr>
+        <p:spPr>
+          <a:xfrm>
+            <a:off x="2514600" y="1755648"/>
+            <a:ext cx="1508760" cy="256032"/>
+          </a:xfrm>
+          <a:prstGeom prst="roundRect">
+            <a:avLst/>
+          </a:prstGeom>
+          <a:solidFill>
+            <a:srgbClr val="ECFDF5"/>
+          </a:solidFill>
+          <a:ln w="12700">
+            <a:solidFill>
+              <a:srgbClr val="0F172A"/>
+            </a:solidFill>
+          </a:ln>
+        </p:spPr>
+        <p:style>
+          <a:lnRef idx="1">
+            <a:schemeClr val="accent1"/>
+          </a:lnRef>
+          <a:fillRef idx="3">
+            <a:schemeClr val="accent1"/>
+          </a:fillRef>
+          <a:effectRef idx="2">
+            <a:schemeClr val="accent1"/>
+          </a:effectRef>
+          <a:fontRef idx="minor">
+            <a:schemeClr val="lt1"/>
+          </a:fontRef>
+        </p:style>
+        <p:txBody>
+          <a:bodyPr rtlCol="0" anchor="ctr" lIns="0" tIns="0" rIns="0" bIns="0"/>
+          <a:lstStyle/>
+          <a:p>
+            <a:pPr algn="ctr">
+              <a:defRPr sz="850" b="1">
+                <a:solidFill>
+                  <a:srgbClr val="0F172A"/>
+                </a:solidFill>
+              </a:defRPr>
+            </a:pPr>
+            <a:r>
+              <a:t>PRIOR ART</a:t>
+            </a:r>
+          </a:p>
+        </p:txBody>
+      </p:sp>
+      <p:sp>
+        <p:nvSpPr>
+          <p:cNvPr id="9" name="Rounded Rectangle 8"/>
+          <p:cNvSpPr/>
+          <p:nvPr/>
+        </p:nvSpPr>
+        <p:spPr>
+          <a:xfrm>
+            <a:off x="4389120" y="1645920"/>
+            <a:ext cx="3429000" cy="4663440"/>
           </a:xfrm>
           <a:prstGeom prst="roundRect">
             <a:avLst/>
@@ -17257,14 +17538,14 @@
       </p:sp>
       <p:sp>
         <p:nvSpPr>
-          <p:cNvPr id="7" name="TextBox 6"/>
+          <p:cNvPr id="10" name="TextBox 9"/>
           <p:cNvSpPr txBox="1"/>
           <p:nvPr/>
         </p:nvSpPr>
         <p:spPr>
           <a:xfrm>
-            <a:off x="877824" y="1792224"/>
-            <a:ext cx="5010912" cy="1901952"/>
+            <a:off x="4535424" y="1792224"/>
+            <a:ext cx="3136392" cy="4370832"/>
           </a:xfrm>
           <a:prstGeom prst="rect">
             <a:avLst/>
@@ -17288,7 +17569,7 @@
               </a:defRPr>
             </a:pPr>
             <a:r>
-              <a:t>The Entropy Minimization Trap (Tent / EATA)</a:t>
+              <a:t>2. Critical Gaps in Prior Art</a:t>
             </a:r>
           </a:p>
           <a:p>
@@ -17303,7 +17584,7 @@
                   <a:srgbClr val="0F172A"/>
                 </a:solidFill>
               </a:rPr>
-              <a:t>•  Core Assumption: </a:t>
+              <a:t>•  Flawed Core Premise: </a:t>
             </a:r>
             <a:r>
               <a:rPr sz="1050">
@@ -17311,7 +17592,7 @@
                   <a:srgbClr val="1E293B"/>
                 </a:solidFill>
               </a:rPr>
-              <a:t>Minimizing prediction entropy H(p) assumes that confident predictions are predominantly correct.</a:t>
+              <a:t>All existing methods assume low entropy = correct predictions. In digital pathology, this triggers catastrophic collapse on 40% of slides.</a:t>
             </a:r>
           </a:p>
           <a:p>
@@ -17326,7 +17607,7 @@
                   <a:srgbClr val="0F172A"/>
                 </a:solidFill>
               </a:rPr>
-              <a:t>•  Histopathology Reality: </a:t>
+              <a:t>•  Scalar Gating Blindness: </a:t>
             </a:r>
             <a:r>
               <a:rPr sz="1050">
@@ -17334,7 +17615,7 @@
                   <a:srgbClr val="1E293B"/>
                 </a:solidFill>
               </a:rPr>
-              <a:t>Severe stain drift causes false predictions to have moderate entropy; minimizing entropy actively reinforces false class assignments.</a:t>
+              <a:t>Fisher weighting (EATA) and gradient-spike checks (SAR) fail because stain drift produces smooth, low-norm gradients that silently drift into collapse.</a:t>
             </a:r>
           </a:p>
           <a:p>
@@ -17349,7 +17630,7 @@
                   <a:srgbClr val="0F172A"/>
                 </a:solidFill>
               </a:rPr>
-              <a:t>•  Feedback Loop: </a:t>
+              <a:t>•  HIPAA &amp; Regulatory Breaches: </a:t>
             </a:r>
             <a:r>
               <a:rPr sz="1050">
@@ -17357,20 +17638,20 @@
                   <a:srgbClr val="1E293B"/>
                 </a:solidFill>
               </a:rPr>
-              <a:t>Corrupted normalization parameters bias the next batch, leading to runaway confirmation bias.</a:t>
-            </a:r>
-          </a:p>
-        </p:txBody>
-      </p:sp>
-      <p:sp>
-        <p:nvSpPr>
-          <p:cNvPr id="8" name="Rounded Rectangle 7"/>
+              <a:t>Continual memory banks (CoTTA, RoTTA) allow Patient A's tissue to pollute Patient B's diagnosis, violating medical privacy.</a:t>
+            </a:r>
+          </a:p>
+        </p:txBody>
+      </p:sp>
+      <p:sp>
+        <p:nvSpPr>
+          <p:cNvPr id="11" name="Rounded Rectangle 10"/>
           <p:cNvSpPr/>
           <p:nvPr/>
         </p:nvSpPr>
         <p:spPr>
           <a:xfrm>
-            <a:off x="4389120" y="1755648"/>
+            <a:off x="6172200" y="1755648"/>
             <a:ext cx="1508760" cy="256032"/>
           </a:xfrm>
           <a:prstGeom prst="roundRect">
@@ -17411,21 +17692,21 @@
               </a:defRPr>
             </a:pPr>
             <a:r>
-              <a:t>FLAWED PREMISE</a:t>
-            </a:r>
-          </a:p>
-        </p:txBody>
-      </p:sp>
-      <p:sp>
-        <p:nvSpPr>
-          <p:cNvPr id="9" name="Rounded Rectangle 8"/>
+              <a:t>IDENTIFIED GAPS</a:t>
+            </a:r>
+          </a:p>
+        </p:txBody>
+      </p:sp>
+      <p:sp>
+        <p:nvSpPr>
+          <p:cNvPr id="12" name="Rounded Rectangle 11"/>
           <p:cNvSpPr/>
           <p:nvPr/>
         </p:nvSpPr>
         <p:spPr>
           <a:xfrm>
-            <a:off x="731520" y="4023360"/>
-            <a:ext cx="5303520" cy="2286000"/>
+            <a:off x="8046720" y="1645920"/>
+            <a:ext cx="3429000" cy="4663440"/>
           </a:xfrm>
           <a:prstGeom prst="roundRect">
             <a:avLst/>
@@ -17435,7 +17716,7 @@
           </a:solidFill>
           <a:ln w="19050">
             <a:solidFill>
-              <a:srgbClr val="DC2626"/>
+              <a:srgbClr val="059669"/>
             </a:solidFill>
           </a:ln>
         </p:spPr>
@@ -17463,14 +17744,14 @@
       </p:sp>
       <p:sp>
         <p:nvSpPr>
-          <p:cNvPr id="10" name="TextBox 9"/>
+          <p:cNvPr id="13" name="TextBox 12"/>
           <p:cNvSpPr txBox="1"/>
           <p:nvPr/>
         </p:nvSpPr>
         <p:spPr>
           <a:xfrm>
-            <a:off x="877824" y="4169664"/>
-            <a:ext cx="5010912" cy="1993392"/>
+            <a:off x="8193024" y="1792224"/>
+            <a:ext cx="3136392" cy="4370832"/>
           </a:xfrm>
           <a:prstGeom prst="rect">
             <a:avLst/>
@@ -17489,12 +17770,12 @@
               </a:spcAft>
               <a:defRPr sz="1300" b="1">
                 <a:solidFill>
-                  <a:srgbClr val="DC2626"/>
+                  <a:srgbClr val="059669"/>
                 </a:solidFill>
               </a:defRPr>
             </a:pPr>
             <a:r>
-              <a:t>Catastrophic Attractor State Collapse</a:t>
+              <a:t>3. What We Are Doing Differently</a:t>
             </a:r>
           </a:p>
           <a:p>
@@ -17509,7 +17790,7 @@
                   <a:srgbClr val="0F172A"/>
                 </a:solidFill>
               </a:rPr>
-              <a:t>•  Single-Class Attractor: </a:t>
+              <a:t>•  Exact Marginal Transport: </a:t>
             </a:r>
             <a:r>
               <a:rPr sz="1050">
@@ -17517,7 +17798,7 @@
                   <a:srgbClr val="1E293B"/>
                 </a:solidFill>
               </a:rPr>
-              <a:t>Batch Normalization running statistics drift until all features collapse into a single degenerate cluster.</a:t>
+              <a:t>Replaces entropy minimization with Sinkhorn Optimal Transport to preserve category geometry without label feedback.</a:t>
             </a:r>
           </a:p>
           <a:p>
@@ -17532,7 +17813,7 @@
                   <a:srgbClr val="0F172A"/>
                 </a:solidFill>
               </a:rPr>
-              <a:t>•  Clinical Consequence: </a:t>
+              <a:t>•  Explicit OOD Slack Channel: </a:t>
             </a:r>
             <a:r>
               <a:rPr sz="1050">
@@ -17540,7 +17821,7 @@
                   <a:srgbClr val="1E293B"/>
                 </a:solidFill>
               </a:rPr>
-              <a:t>The network predicts 100% of tissue patches as normal, driving cancer detection F1-score from 0.85 down to 0.05.</a:t>
+              <a:t>Routes non-neoplastic tissue artifacts (surgical ink, air bubbles) into a slack channel to protect diagnostic prototypes.</a:t>
             </a:r>
           </a:p>
           <a:p>
@@ -17555,7 +17836,7 @@
                   <a:srgbClr val="0F172A"/>
                 </a:solidFill>
               </a:rPr>
-              <a:t>•  40% Collapse Rate: </a:t>
+              <a:t>•  Provable Finite-Sample Safety: </a:t>
             </a:r>
             <a:r>
               <a:rPr sz="1050">
@@ -17563,31 +17844,31 @@
                   <a:srgbClr val="1E293B"/>
                 </a:solidFill>
               </a:rPr>
-              <a:t>On CAMELYON17 Center 4, standard Tent collapses on 40% of patient slides (e.g., Slide 29 drops to 0.51 AUROC).</a:t>
-            </a:r>
-          </a:p>
-        </p:txBody>
-      </p:sp>
-      <p:sp>
-        <p:nvSpPr>
-          <p:cNvPr id="11" name="Rounded Rectangle 10"/>
+              <a:t>Establishes Theorem 1 conformal bounds with sub-2ms GPU rollback and deterministic episodic per-slide resets.</a:t>
+            </a:r>
+          </a:p>
+        </p:txBody>
+      </p:sp>
+      <p:sp>
+        <p:nvSpPr>
+          <p:cNvPr id="14" name="Rounded Rectangle 13"/>
           <p:cNvSpPr/>
           <p:nvPr/>
         </p:nvSpPr>
         <p:spPr>
           <a:xfrm>
-            <a:off x="4389120" y="4133088"/>
+            <a:off x="9829800" y="1755648"/>
             <a:ext cx="1508760" cy="256032"/>
           </a:xfrm>
           <a:prstGeom prst="roundRect">
             <a:avLst/>
           </a:prstGeom>
           <a:solidFill>
-            <a:srgbClr val="FEF2F2"/>
+            <a:srgbClr val="ECFDF5"/>
           </a:solidFill>
           <a:ln w="12700">
             <a:solidFill>
-              <a:srgbClr val="DC2626"/>
+              <a:srgbClr val="059669"/>
             </a:solidFill>
           </a:ln>
         </p:spPr>
@@ -17612,116 +17893,12 @@
             <a:pPr algn="ctr">
               <a:defRPr sz="850" b="1">
                 <a:solidFill>
-                  <a:srgbClr val="DC2626"/>
+                  <a:srgbClr val="059669"/>
                 </a:solidFill>
               </a:defRPr>
             </a:pPr>
             <a:r>
-              <a:t>40% COLLAPSE</a:t>
-            </a:r>
-          </a:p>
-        </p:txBody>
-      </p:sp>
-      <p:sp>
-        <p:nvSpPr>
-          <p:cNvPr id="12" name="Rounded Rectangle 11"/>
-          <p:cNvSpPr/>
-          <p:nvPr/>
-        </p:nvSpPr>
-        <p:spPr>
-          <a:xfrm>
-            <a:off x="6254496" y="2150246"/>
-            <a:ext cx="5230368" cy="3929106"/>
-          </a:xfrm>
-          <a:prstGeom prst="roundRect">
-            <a:avLst/>
-          </a:prstGeom>
-          <a:solidFill>
-            <a:srgbClr val="FFFFFF"/>
-          </a:solidFill>
-          <a:ln w="12700">
-            <a:solidFill>
-              <a:srgbClr val="E2E8F0"/>
-            </a:solidFill>
-          </a:ln>
-        </p:spPr>
-        <p:style>
-          <a:lnRef idx="1">
-            <a:schemeClr val="accent1"/>
-          </a:lnRef>
-          <a:fillRef idx="3">
-            <a:schemeClr val="accent1"/>
-          </a:fillRef>
-          <a:effectRef idx="2">
-            <a:schemeClr val="accent1"/>
-          </a:effectRef>
-          <a:fontRef idx="minor">
-            <a:schemeClr val="lt1"/>
-          </a:fontRef>
-        </p:style>
-        <p:txBody>
-          <a:bodyPr rtlCol="0" anchor="ctr"/>
-          <a:lstStyle/>
-          <a:p>
-            <a:pPr algn="ctr"/>
-          </a:p>
-        </p:txBody>
-      </p:sp>
-      <p:pic>
-        <p:nvPicPr>
-          <p:cNvPr id="13" name="Picture 12" descr="fig_tent_collapse_mechanism.png"/>
-          <p:cNvPicPr>
-            <a:picLocks noChangeAspect="1"/>
-          </p:cNvPicPr>
-          <p:nvPr/>
-        </p:nvPicPr>
-        <p:blipFill>
-          <a:blip r:embed="rId2"/>
-          <a:stretch>
-            <a:fillRect/>
-          </a:stretch>
-        </p:blipFill>
-        <p:spPr>
-          <a:xfrm>
-            <a:off x="6309360" y="2205110"/>
-            <a:ext cx="5120640" cy="3545058"/>
-          </a:xfrm>
-          <a:prstGeom prst="rect">
-            <a:avLst/>
-          </a:prstGeom>
-        </p:spPr>
-      </p:pic>
-      <p:sp>
-        <p:nvSpPr>
-          <p:cNvPr id="14" name="TextBox 13"/>
-          <p:cNvSpPr txBox="1"/>
-          <p:nvPr/>
-        </p:nvSpPr>
-        <p:spPr>
-          <a:xfrm>
-            <a:off x="6309360" y="5795889"/>
-            <a:ext cx="5120640" cy="228600"/>
-          </a:xfrm>
-          <a:prstGeom prst="rect">
-            <a:avLst/>
-          </a:prstGeom>
-          <a:noFill/>
-        </p:spPr>
-        <p:txBody>
-          <a:bodyPr wrap="square" lIns="0" tIns="0" rIns="0" bIns="0">
-            <a:spAutoFit/>
-          </a:bodyPr>
-          <a:lstStyle/>
-          <a:p>
-            <a:pPr algn="ctr">
-              <a:defRPr sz="850" i="1">
-                <a:solidFill>
-                  <a:srgbClr val="64748B"/>
-                </a:solidFill>
-              </a:defRPr>
-            </a:pPr>
-            <a:r>
-              <a:t>Empirical Collapse: Tent entropy optimization destroys latent feature margins across streaming WSI batches.</a:t>
+              <a:t>OUR INNOVATIONS</a:t>
             </a:r>
           </a:p>
         </p:txBody>
@@ -18666,7 +18843,7 @@
               </a:defRPr>
             </a:pPr>
             <a:r>
-              <a:t>PROPOSED FRAMEWORK</a:t>
+              <a:t>WORKFLOW &amp; EXECUTION PIPELINE</a:t>
             </a:r>
           </a:p>
         </p:txBody>
@@ -18701,7 +18878,7 @@
               </a:defRPr>
             </a:pPr>
             <a:r>
-              <a:t>SafeAdapt: A Deterministic, Fail-Closed TTA Architecture</a:t>
+              <a:t>End-to-End Workflow Pipeline &amp; System Architecture</a:t>
             </a:r>
           </a:p>
         </p:txBody>
@@ -18755,7 +18932,7 @@
               </a:defRPr>
             </a:pPr>
             <a:r>
-              <a:t>KEY TAKEAWAY:  SafeAdapt introduces geometry-preserving optimal transport, contextual artifact rejection, and finite-sample risk bounds.</a:t>
+              <a:t>KEY TAKEAWAY:  Four interlocking safeguards execute in a single forward-backward pass per patch batch, with deterministic state reset per slide.</a:t>
             </a:r>
           </a:p>
         </p:txBody>
@@ -18913,7 +19090,7 @@
               </a:defRPr>
             </a:pPr>
             <a:r>
-              <a:t>1. Dual-Stream Anchor</a:t>
+              <a:t>Step 1: Dual-Stream Anchor</a:t>
             </a:r>
           </a:p>
           <a:p>
@@ -18928,7 +19105,7 @@
               </a:defRPr>
             </a:pPr>
             <a:r>
-              <a:t>Maintains frozen source anchor theta_0 in parallel with adaptive student theta_t to preserve diagnostic geometry.</a:t>
+              <a:t>Streams patches through frozen anchor theta_0 in parallel with adaptive student theta_t to preserve diagnostic geometry.</a:t>
             </a:r>
           </a:p>
         </p:txBody>
@@ -18982,7 +19159,7 @@
               </a:defRPr>
             </a:pPr>
             <a:r>
-              <a:t>2. Sinkhorn Optimal Transport</a:t>
+              <a:t>Step 2: Sinkhorn Optimal Transport</a:t>
             </a:r>
           </a:p>
           <a:p>
@@ -19051,7 +19228,7 @@
               </a:defRPr>
             </a:pPr>
             <a:r>
-              <a:t>3. Memory Routing (CMR)</a:t>
+              <a:t>Step 3: Memory Routing (CMR)</a:t>
             </a:r>
           </a:p>
           <a:p>
@@ -19120,7 +19297,7 @@
               </a:defRPr>
             </a:pPr>
             <a:r>
-              <a:t>4. Conformal Risk Rollback</a:t>
+              <a:t>Step 4: Conformal Risk Rollback</a:t>
             </a:r>
           </a:p>
           <a:p>

</xml_diff>